<commit_message>
Update thesis defense presentation files
</commit_message>
<xml_diff>
--- a/defense-presentation/Michele_Garbelotto_Discussione.pptx
+++ b/defense-presentation/Michele_Garbelotto_Discussione.pptx
@@ -9468,7 +9468,7 @@
               </a:defRPr>
             </a:pPr>
             <a:r>
-              <a:rPr sz="2550" b="1">
+              <a:rPr sz="2550" b="1" dirty="0" err="1">
                 <a:solidFill>
                   <a:srgbClr val="AA0004"/>
                 </a:solidFill>
@@ -9476,7 +9476,40 @@
                 <a:ea typeface="Arial"/>
                 <a:cs typeface="Arial"/>
               </a:rPr>
-              <a:t>Controllo della manipolazione e H1</a:t>
+              <a:t>Controllo</a:t>
+            </a:r>
+            <a:r>
+              <a:rPr sz="2550" b="1" dirty="0">
+                <a:solidFill>
+                  <a:srgbClr val="AA0004"/>
+                </a:solidFill>
+                <a:latin typeface="Arial"/>
+                <a:ea typeface="Arial"/>
+                <a:cs typeface="Arial"/>
+              </a:rPr>
+              <a:t> della </a:t>
+            </a:r>
+            <a:r>
+              <a:rPr sz="2550" b="1" dirty="0" err="1">
+                <a:solidFill>
+                  <a:srgbClr val="AA0004"/>
+                </a:solidFill>
+                <a:latin typeface="Arial"/>
+                <a:ea typeface="Arial"/>
+                <a:cs typeface="Arial"/>
+              </a:rPr>
+              <a:t>manipolazione</a:t>
+            </a:r>
+            <a:r>
+              <a:rPr sz="2550" b="1" dirty="0">
+                <a:solidFill>
+                  <a:srgbClr val="AA0004"/>
+                </a:solidFill>
+                <a:latin typeface="Arial"/>
+                <a:ea typeface="Arial"/>
+                <a:cs typeface="Arial"/>
+              </a:rPr>
+              <a:t> e H1</a:t>
             </a:r>
           </a:p>
         </p:txBody>
@@ -12813,7 +12846,7 @@
               </a:defRPr>
             </a:pPr>
             <a:r>
-              <a:rPr sz="2550" b="1">
+              <a:rPr sz="2550" b="1" dirty="0">
                 <a:solidFill>
                   <a:srgbClr val="AA0004"/>
                 </a:solidFill>
@@ -12821,8 +12854,27 @@
                 <a:ea typeface="Arial"/>
                 <a:cs typeface="Arial"/>
               </a:rPr>
-              <a:t>H3 · Inizio della ricerca e direzione possibile</a:t>
-            </a:r>
+              <a:t>H3 · </a:t>
+            </a:r>
+            <a:r>
+              <a:rPr lang="it-IT" sz="2550" b="1" dirty="0">
+                <a:solidFill>
+                  <a:srgbClr val="AA0004"/>
+                </a:solidFill>
+                <a:latin typeface="Arial"/>
+                <a:ea typeface="Arial"/>
+                <a:cs typeface="Arial"/>
+              </a:rPr>
+              <a:t>Confronto verso l’alto e inizio della ricerca</a:t>
+            </a:r>
+            <a:endParaRPr sz="2550" b="1" dirty="0">
+              <a:solidFill>
+                <a:srgbClr val="AA0004"/>
+              </a:solidFill>
+              <a:latin typeface="Arial"/>
+              <a:ea typeface="Arial"/>
+              <a:cs typeface="Arial"/>
+            </a:endParaRPr>
           </a:p>
         </p:txBody>
       </p:sp>
@@ -14680,7 +14732,7 @@
               </a:defRPr>
             </a:pPr>
             <a:r>
-              <a:rPr sz="2175" b="1" dirty="0" err="1">
+              <a:rPr lang="it-IT" sz="2175" b="1" dirty="0">
                 <a:solidFill>
                   <a:srgbClr val="AA0004"/>
                 </a:solidFill>
@@ -14688,29 +14740,7 @@
                 <a:ea typeface="Arial"/>
                 <a:cs typeface="Arial"/>
               </a:rPr>
-              <a:t>Direzione</a:t>
-            </a:r>
-            <a:r>
-              <a:rPr sz="2175" b="1" dirty="0">
-                <a:solidFill>
-                  <a:srgbClr val="AA0004"/>
-                </a:solidFill>
-                <a:latin typeface="Arial"/>
-                <a:ea typeface="Arial"/>
-                <a:cs typeface="Arial"/>
-              </a:rPr>
-              <a:t> </a:t>
-            </a:r>
-            <a:r>
-              <a:rPr lang="it-IT" sz="2175" b="1" dirty="0">
-                <a:solidFill>
-                  <a:srgbClr val="AA0004"/>
-                </a:solidFill>
-                <a:latin typeface="Arial"/>
-                <a:ea typeface="Arial"/>
-                <a:cs typeface="Arial"/>
-              </a:rPr>
-              <a:t>di confronto</a:t>
+              <a:t>Confronto verso l’alto</a:t>
             </a:r>
             <a:endParaRPr sz="2175" b="1" dirty="0">
               <a:solidFill>
@@ -14949,7 +14979,7 @@
                 <a:ea typeface="Arial"/>
                 <a:cs typeface="Arial"/>
               </a:rPr>
-              <a:t>.</a:t>
+              <a:t>. Possibile differenza tra avvio ed estensione.</a:t>
             </a:r>
             <a:endParaRPr sz="2100" b="0" dirty="0">
               <a:solidFill>

</xml_diff>

<commit_message>
Remove speaker notes from defense presentation
</commit_message>
<xml_diff>
--- a/defense-presentation/Michele_Garbelotto_Discussione.pptx
+++ b/defense-presentation/Michele_Garbelotto_Discussione.pptx
@@ -792,24 +792,7 @@
         <p:txBody>
           <a:bodyPr/>
           <a:lstStyle/>
-          <a:p>
-            <a:r>
-              <a:t>Tempo guida: 40 secondi.</a:t>
-            </a:r>
-          </a:p>
-          <a:p>
-            <a:endParaRPr/>
-          </a:p>
-          <a:p>
-            <a:r>
-              <a:t>Questa roulette chiarisce come il compito rende possibile la comparazione verso l’alto o verso il basso. Se ottengo dieci dollari, l’esito peggiore, posso osservare un esito uguale oppure cinquanta dollari, quindi migliore. Se ottengo cinquanta, posso osservare un esito uguale oppure dieci, quindi peggiore. In entrambi i casi l’esito richiesto è casuale. Il partecipante decide se chiedere informazioni, non la persona o la direzione del confronto. Per questo la direzione disponibile e l’esito proprio coincidono nel disegno.</a:t>
-            </a:r>
-          </a:p>
-          <a:p>
-            <a:r>
-              <a:t>Fonte: slide 21 originale; empirical_study.qmd:21 e metodo.</a:t>
-            </a:r>
-          </a:p>
+          <a:p/>
         </p:txBody>
       </p:sp>
       <p:sp>
@@ -882,24 +865,7 @@
         <p:txBody>
           <a:bodyPr/>
           <a:lstStyle/>
-          <a:p>
-            <a:r>
-              <a:t>Tempo guida: 35 secondi.</a:t>
-            </a:r>
-          </a:p>
-          <a:p>
-            <a:endParaRPr/>
-          </a:p>
-          <a:p>
-            <a:r>
-              <a:t>La distribuzione mostra che in 368 trial su 840, il 43,8 per cento, non viene richiesto alcun esito. Per la ricerca abbiamo utilizzato un modello hurdle entro la famiglia dei modelli a effetti misti, che tengono conto delle osservazioni ripetute. Una componente riguarda se iniziare e l’altra quanti esiti richiedere dopo l’inizio. Questa distinzione era motivata dai due aspetti osservabili del comportamento. La distribuzione ne mostra la pertinenza descrittiva, senza dimostrare zeri in eccesso rispetto a un modello alternativo o due meccanismi psicologici distinti.</a:t>
-            </a:r>
-          </a:p>
-          <a:p>
-            <a:r>
-              <a:t>Fonti: empirical_study.qmd:85–107,151–198; overall_trial_sampling_frequency.csv.</a:t>
-            </a:r>
-          </a:p>
+          <a:p/>
         </p:txBody>
       </p:sp>
       <p:sp>
@@ -972,24 +938,7 @@
         <p:txBody>
           <a:bodyPr/>
           <a:lstStyle/>
-          <a:p>
-            <a:r>
-              <a:t>Tempo guida: 40 secondi.</a:t>
-            </a:r>
-          </a:p>
-          <a:p>
-            <a:endParaRPr/>
-          </a:p>
-          <a:p>
-            <a:r>
-              <a:t>La manipolazione ha prodotto la differenza affettiva attesa: la felicità media era circa sessantadue nel guadagno e quarantacinque nella perdita. Il contrasto stimato è di meno diciassette virgola sessantotto punti. Per H1, invece, non emerge evidenza della minore ricerca prevista nella perdita: né per la probabilità di iniziare, né per l’estensione condizionata all’inizio. Gli intervalli comprendono il valore uno. Questo non dimostra che i domini siano equivalenti o che non possa esistere alcun effetto.</a:t>
-            </a:r>
-          </a:p>
-          <a:p>
-            <a:r>
-              <a:t>Fonti: empirical_study.qmd:287–295; docs/context/provenance.md, Happiness manipulation check e H1.</a:t>
-            </a:r>
-          </a:p>
+          <a:p/>
         </p:txBody>
       </p:sp>
       <p:sp>
@@ -1062,24 +1011,7 @@
         <p:txBody>
           <a:bodyPr/>
           <a:lstStyle/>
-          <a:p>
-            <a:r>
-              <a:t>Tempo guida: 50 secondi.</a:t>
-            </a:r>
-          </a:p>
-          <a:p>
-            <a:endParaRPr/>
-          </a:p>
-          <a:p>
-            <a:r>
-              <a:t>Il grafico descrittivo mostra la probabilità osservata di iniziare la ricerca ai diversi punteggi di identificazione: i punti sono medie per partecipante con intervalli al 95 per cento. Nel modello, aggiustato per dominio, un punto in più di identificazione è associato a odds di inizio maggiori del 23 per cento. La direzione è quindi opposta a H2b. Non emerge evidenza per l’estensione. Anche H2a e la mediazione non ricevono supporto. L’identificazione è misurata dopo il blocco: stiamo descrivendo un’associazione nello stesso blocco, non una direzione causale dimostrata.</a:t>
-            </a:r>
-          </a:p>
-          <a:p>
-            <a:r>
-              <a:t>Fonti: empirical_study.qmd:297–348; grafico originale slide 31. Campione H2b: 633 trial, 211 blocchi campionati, 119 persone. I trial con zero richieste all’interno di quei blocchi restano inclusi.</a:t>
-            </a:r>
-          </a:p>
+          <a:p/>
         </p:txBody>
       </p:sp>
       <p:sp>
@@ -1152,24 +1084,7 @@
         <p:txBody>
           <a:bodyPr/>
           <a:lstStyle/>
-          <a:p>
-            <a:r>
-              <a:t>Tempo guida: 45 secondi.</a:t>
-            </a:r>
-          </a:p>
-          <a:p>
-            <a:endParaRPr/>
-          </a:p>
-          <a:p>
-            <a:r>
-              <a:t>Dopo l’esito peggiore, quando erano possibili confronti laterali o verso l’alto, la probabilità osservata di almeno una richiesta era il 60,8 per cento. Dopo l’esito migliore era il 52,8 per cento. Il modello stima un odds ratio di 1,65 e l’intervallo non comprende uno. H3 riceve quindi supporto per l’inizio della ricerca. Per l’estensione non emerge evidenza di associazione. Il confronto riguarda condizioni di disponibilità della direzione, non la scelta volontaria di target superiori.</a:t>
-            </a:r>
-          </a:p>
-          <a:p>
-            <a:r>
-              <a:t>Fonti: empirical_study.qmd:350–352; grafico originale slide 30. 840 trial, 140 partecipanti. Le probabilità del grafico sono descrittive, mediate a livello di partecipante, non predizioni modellistiche.</a:t>
-            </a:r>
-          </a:p>
+          <a:p/>
         </p:txBody>
       </p:sp>
       <p:sp>
@@ -1242,499 +1157,7 @@
         <p:txBody>
           <a:bodyPr/>
           <a:lstStyle/>
-          <a:p>
-            <a:r>
-              <a:rPr dirty="0"/>
-              <a:t>Tempo </a:t>
-            </a:r>
-            <a:r>
-              <a:rPr dirty="0" err="1"/>
-              <a:t>guida</a:t>
-            </a:r>
-            <a:r>
-              <a:rPr dirty="0"/>
-              <a:t>: 40 secondi.</a:t>
-            </a:r>
-          </a:p>
-          <a:p>
-            <a:endParaRPr dirty="0"/>
-          </a:p>
-          <a:p>
-            <a:r>
-              <a:rPr dirty="0"/>
-              <a:t>Il </a:t>
-            </a:r>
-            <a:r>
-              <a:rPr dirty="0" err="1"/>
-              <a:t>quadro</a:t>
-            </a:r>
-            <a:r>
-              <a:rPr dirty="0"/>
-              <a:t> </a:t>
-            </a:r>
-            <a:r>
-              <a:rPr dirty="0" err="1"/>
-              <a:t>complessivo</a:t>
-            </a:r>
-            <a:r>
-              <a:rPr dirty="0"/>
-              <a:t> </a:t>
-            </a:r>
-            <a:r>
-              <a:rPr dirty="0" err="1"/>
-              <a:t>presenta</a:t>
-            </a:r>
-            <a:r>
-              <a:rPr dirty="0"/>
-              <a:t> </a:t>
-            </a:r>
-            <a:r>
-              <a:rPr dirty="0" err="1"/>
-              <a:t>tre</a:t>
-            </a:r>
-            <a:r>
-              <a:rPr dirty="0"/>
-              <a:t> </a:t>
-            </a:r>
-            <a:r>
-              <a:rPr dirty="0" err="1"/>
-              <a:t>aspetti</a:t>
-            </a:r>
-            <a:r>
-              <a:rPr dirty="0"/>
-              <a:t>. Primo: il </a:t>
-            </a:r>
-            <a:r>
-              <a:rPr dirty="0" err="1"/>
-              <a:t>dominio</a:t>
-            </a:r>
-            <a:r>
-              <a:rPr dirty="0"/>
-              <a:t> ha </a:t>
-            </a:r>
-            <a:r>
-              <a:rPr dirty="0" err="1"/>
-              <a:t>modificato</a:t>
-            </a:r>
-            <a:r>
-              <a:rPr dirty="0"/>
-              <a:t> la </a:t>
-            </a:r>
-            <a:r>
-              <a:rPr dirty="0" err="1"/>
-              <a:t>felicità</a:t>
-            </a:r>
-            <a:r>
-              <a:rPr dirty="0"/>
-              <a:t>, ma non </a:t>
-            </a:r>
-            <a:r>
-              <a:rPr dirty="0" err="1"/>
-              <a:t>abbiamo</a:t>
-            </a:r>
-            <a:r>
-              <a:rPr dirty="0"/>
-              <a:t> </a:t>
-            </a:r>
-            <a:r>
-              <a:rPr dirty="0" err="1"/>
-              <a:t>osservato</a:t>
-            </a:r>
-            <a:r>
-              <a:rPr dirty="0"/>
-              <a:t> la </a:t>
-            </a:r>
-            <a:r>
-              <a:rPr dirty="0" err="1"/>
-              <a:t>differenza</a:t>
-            </a:r>
-            <a:r>
-              <a:rPr dirty="0"/>
-              <a:t> </a:t>
-            </a:r>
-            <a:r>
-              <a:rPr dirty="0" err="1"/>
-              <a:t>prevista</a:t>
-            </a:r>
-            <a:r>
-              <a:rPr dirty="0"/>
-              <a:t> </a:t>
-            </a:r>
-            <a:r>
-              <a:rPr dirty="0" err="1"/>
-              <a:t>nella</a:t>
-            </a:r>
-            <a:r>
-              <a:rPr dirty="0"/>
-              <a:t> </a:t>
-            </a:r>
-            <a:r>
-              <a:rPr dirty="0" err="1"/>
-              <a:t>ricerca</a:t>
-            </a:r>
-            <a:r>
-              <a:rPr dirty="0"/>
-              <a:t>. Secondo: </a:t>
-            </a:r>
-            <a:r>
-              <a:rPr dirty="0" err="1"/>
-              <a:t>una</a:t>
-            </a:r>
-            <a:r>
-              <a:rPr dirty="0"/>
-              <a:t> </a:t>
-            </a:r>
-            <a:r>
-              <a:rPr dirty="0" err="1"/>
-              <a:t>maggiore</a:t>
-            </a:r>
-            <a:r>
-              <a:rPr dirty="0"/>
-              <a:t> </a:t>
-            </a:r>
-            <a:r>
-              <a:rPr dirty="0" err="1"/>
-              <a:t>identificazione</a:t>
-            </a:r>
-            <a:r>
-              <a:rPr dirty="0"/>
-              <a:t> </a:t>
-            </a:r>
-            <a:r>
-              <a:rPr dirty="0" err="1"/>
-              <a:t>si</a:t>
-            </a:r>
-            <a:r>
-              <a:rPr dirty="0"/>
-              <a:t> </a:t>
-            </a:r>
-            <a:r>
-              <a:rPr dirty="0" err="1"/>
-              <a:t>associa</a:t>
-            </a:r>
-            <a:r>
-              <a:rPr dirty="0"/>
-              <a:t> a un </a:t>
-            </a:r>
-            <a:r>
-              <a:rPr dirty="0" err="1"/>
-              <a:t>avvio</a:t>
-            </a:r>
-            <a:r>
-              <a:rPr dirty="0"/>
-              <a:t> </a:t>
-            </a:r>
-            <a:r>
-              <a:rPr dirty="0" err="1"/>
-              <a:t>più</a:t>
-            </a:r>
-            <a:r>
-              <a:rPr dirty="0"/>
-              <a:t> </a:t>
-            </a:r>
-            <a:r>
-              <a:rPr dirty="0" err="1"/>
-              <a:t>frequente</a:t>
-            </a:r>
-            <a:r>
-              <a:rPr dirty="0"/>
-              <a:t>, in </a:t>
-            </a:r>
-            <a:r>
-              <a:rPr dirty="0" err="1"/>
-              <a:t>direzione</a:t>
-            </a:r>
-            <a:r>
-              <a:rPr dirty="0"/>
-              <a:t> </a:t>
-            </a:r>
-            <a:r>
-              <a:rPr dirty="0" err="1"/>
-              <a:t>contraria</a:t>
-            </a:r>
-            <a:r>
-              <a:rPr dirty="0"/>
-              <a:t> alla </a:t>
-            </a:r>
-            <a:r>
-              <a:rPr dirty="0" err="1"/>
-              <a:t>previsione</a:t>
-            </a:r>
-            <a:r>
-              <a:rPr dirty="0"/>
-              <a:t> e senza </a:t>
-            </a:r>
-            <a:r>
-              <a:rPr dirty="0" err="1"/>
-              <a:t>identificare</a:t>
-            </a:r>
-            <a:r>
-              <a:rPr dirty="0"/>
-              <a:t> il </a:t>
-            </a:r>
-            <a:r>
-              <a:rPr dirty="0" err="1"/>
-              <a:t>meccanismo</a:t>
-            </a:r>
-            <a:r>
-              <a:rPr dirty="0"/>
-              <a:t>. Terzo: </a:t>
-            </a:r>
-            <a:r>
-              <a:rPr dirty="0" err="1"/>
-              <a:t>l’avvio</a:t>
-            </a:r>
-            <a:r>
-              <a:rPr dirty="0"/>
-              <a:t> è </a:t>
-            </a:r>
-            <a:r>
-              <a:rPr dirty="0" err="1"/>
-              <a:t>più</a:t>
-            </a:r>
-            <a:r>
-              <a:rPr dirty="0"/>
-              <a:t> </a:t>
-            </a:r>
-            <a:r>
-              <a:rPr dirty="0" err="1"/>
-              <a:t>frequente</a:t>
-            </a:r>
-            <a:r>
-              <a:rPr dirty="0"/>
-              <a:t> </a:t>
-            </a:r>
-            <a:r>
-              <a:rPr dirty="0" err="1"/>
-              <a:t>quando</a:t>
-            </a:r>
-            <a:r>
-              <a:rPr dirty="0"/>
-              <a:t> è </a:t>
-            </a:r>
-            <a:r>
-              <a:rPr dirty="0" err="1"/>
-              <a:t>disponibile</a:t>
-            </a:r>
-            <a:r>
-              <a:rPr dirty="0"/>
-              <a:t> il </a:t>
-            </a:r>
-            <a:r>
-              <a:rPr dirty="0" err="1"/>
-              <a:t>confronto</a:t>
-            </a:r>
-            <a:r>
-              <a:rPr dirty="0"/>
-              <a:t> verso </a:t>
-            </a:r>
-            <a:r>
-              <a:rPr dirty="0" err="1"/>
-              <a:t>l’alto</a:t>
-            </a:r>
-            <a:r>
-              <a:rPr dirty="0"/>
-              <a:t>, ma </a:t>
-            </a:r>
-            <a:r>
-              <a:rPr dirty="0" err="1"/>
-              <a:t>questa</a:t>
-            </a:r>
-            <a:r>
-              <a:rPr dirty="0"/>
-              <a:t> </a:t>
-            </a:r>
-            <a:r>
-              <a:rPr dirty="0" err="1"/>
-              <a:t>condizione</a:t>
-            </a:r>
-            <a:r>
-              <a:rPr dirty="0"/>
-              <a:t> coincide con </a:t>
-            </a:r>
-            <a:r>
-              <a:rPr dirty="0" err="1"/>
-              <a:t>l’esito</a:t>
-            </a:r>
-            <a:r>
-              <a:rPr dirty="0"/>
-              <a:t> proprio </a:t>
-            </a:r>
-            <a:r>
-              <a:rPr dirty="0" err="1"/>
-              <a:t>peggiore</a:t>
-            </a:r>
-            <a:r>
-              <a:rPr dirty="0"/>
-              <a:t>. </a:t>
-            </a:r>
-            <a:r>
-              <a:rPr dirty="0" err="1"/>
-              <a:t>Separare</a:t>
-            </a:r>
-            <a:r>
-              <a:rPr dirty="0"/>
-              <a:t> </a:t>
-            </a:r>
-            <a:r>
-              <a:rPr dirty="0" err="1"/>
-              <a:t>inizio</a:t>
-            </a:r>
-            <a:r>
-              <a:rPr dirty="0"/>
-              <a:t> ed </a:t>
-            </a:r>
-            <a:r>
-              <a:rPr dirty="0" err="1"/>
-              <a:t>estensione</a:t>
-            </a:r>
-            <a:r>
-              <a:rPr dirty="0"/>
-              <a:t> </a:t>
-            </a:r>
-            <a:r>
-              <a:rPr dirty="0" err="1"/>
-              <a:t>aiuta</a:t>
-            </a:r>
-            <a:r>
-              <a:rPr dirty="0"/>
-              <a:t> a </a:t>
-            </a:r>
-            <a:r>
-              <a:rPr dirty="0" err="1"/>
-              <a:t>descrivere</a:t>
-            </a:r>
-            <a:r>
-              <a:rPr dirty="0"/>
-              <a:t> il </a:t>
-            </a:r>
-            <a:r>
-              <a:rPr dirty="0" err="1"/>
-              <a:t>comportamento</a:t>
-            </a:r>
-            <a:r>
-              <a:rPr dirty="0"/>
-              <a:t>; la </a:t>
-            </a:r>
-            <a:r>
-              <a:rPr dirty="0" err="1"/>
-              <a:t>diversa</a:t>
-            </a:r>
-            <a:r>
-              <a:rPr dirty="0"/>
-              <a:t> </a:t>
-            </a:r>
-            <a:r>
-              <a:rPr dirty="0" err="1"/>
-              <a:t>significatività</a:t>
-            </a:r>
-            <a:r>
-              <a:rPr dirty="0"/>
-              <a:t> non </a:t>
-            </a:r>
-            <a:r>
-              <a:rPr dirty="0" err="1"/>
-              <a:t>dimostra</a:t>
-            </a:r>
-            <a:r>
-              <a:rPr dirty="0"/>
-              <a:t> </a:t>
-            </a:r>
-            <a:r>
-              <a:rPr dirty="0" err="1"/>
-              <a:t>però</a:t>
-            </a:r>
-            <a:r>
-              <a:rPr dirty="0"/>
-              <a:t> </a:t>
-            </a:r>
-            <a:r>
-              <a:rPr dirty="0" err="1"/>
-              <a:t>che</a:t>
-            </a:r>
-            <a:r>
-              <a:rPr dirty="0"/>
-              <a:t> </a:t>
-            </a:r>
-            <a:r>
-              <a:rPr dirty="0" err="1"/>
-              <a:t>i</a:t>
-            </a:r>
-            <a:r>
-              <a:rPr dirty="0"/>
-              <a:t> </a:t>
-            </a:r>
-            <a:r>
-              <a:rPr dirty="0" err="1"/>
-              <a:t>coefficienti</a:t>
-            </a:r>
-            <a:r>
-              <a:rPr dirty="0"/>
-              <a:t> o </a:t>
-            </a:r>
-            <a:r>
-              <a:rPr dirty="0" err="1"/>
-              <a:t>i</a:t>
-            </a:r>
-            <a:r>
-              <a:rPr dirty="0"/>
-              <a:t> </a:t>
-            </a:r>
-            <a:r>
-              <a:rPr dirty="0" err="1"/>
-              <a:t>meccanismi</a:t>
-            </a:r>
-            <a:r>
-              <a:rPr dirty="0"/>
-              <a:t> </a:t>
-            </a:r>
-            <a:r>
-              <a:rPr dirty="0" err="1"/>
-              <a:t>siano</a:t>
-            </a:r>
-            <a:r>
-              <a:rPr dirty="0"/>
-              <a:t> </a:t>
-            </a:r>
-            <a:r>
-              <a:rPr dirty="0" err="1"/>
-              <a:t>diversi</a:t>
-            </a:r>
-            <a:r>
-              <a:rPr dirty="0"/>
-              <a:t>.</a:t>
-            </a:r>
-          </a:p>
-          <a:p>
-            <a:r>
-              <a:rPr dirty="0"/>
-              <a:t>Fonte: </a:t>
-            </a:r>
-            <a:r>
-              <a:rPr dirty="0" err="1"/>
-              <a:t>empirical_study.qmd</a:t>
-            </a:r>
-            <a:r>
-              <a:rPr dirty="0"/>
-              <a:t>, </a:t>
-            </a:r>
-            <a:r>
-              <a:rPr dirty="0" err="1"/>
-              <a:t>risultati</a:t>
-            </a:r>
-            <a:r>
-              <a:rPr dirty="0"/>
-              <a:t> e </a:t>
-            </a:r>
-            <a:r>
-              <a:rPr dirty="0" err="1"/>
-              <a:t>discussione</a:t>
-            </a:r>
-            <a:r>
-              <a:rPr dirty="0"/>
-              <a:t>.</a:t>
-            </a:r>
-          </a:p>
+          <a:p/>
         </p:txBody>
       </p:sp>
       <p:sp>
@@ -1812,24 +1235,7 @@
         <p:txBody>
           <a:bodyPr/>
           <a:lstStyle/>
-          <a:p>
-            <a:r>
-              <a:t>Tempo guida: 55 secondi.</a:t>
-            </a:r>
-          </a:p>
-          <a:p>
-            <a:endParaRPr/>
-          </a:p>
-          <a:p>
-            <a:r>
-              <a:t>I primi due limiti riguardano direttamente le ipotesi. Per H2, il disagio necessario a prevedere evitamento era un presupposto non misurato. Per H3, ricevere l’esito peggiore coincideva con la possibilità di confronto verso l’alto: non possiamo separare questi fattori. Inoltre, registriamo la richiesta di esiti, ma non se la comparazione sia poi avvenuta. Il disegno limita la scelta alla roulette corrente e allo stesso dominio. Gli standard erano sconosciuti, identificati da un nome e da un esito casuale, e la loro rilevanza personale potrebbe essere ridotta. Infine manca una condizione con informazioni equivalenti attribuite a una fonte non sociale.</a:t>
-            </a:r>
-          </a:p>
-          <a:p>
-            <a:r>
-              <a:t>Fonti: empirical_study.qmd:451–463 e scelte redazionali nel piano esecutivo.</a:t>
-            </a:r>
-          </a:p>
+          <a:p/>
         </p:txBody>
       </p:sp>
       <p:sp>
@@ -1907,24 +1313,7 @@
         <p:txBody>
           <a:bodyPr/>
           <a:lstStyle/>
-          <a:p>
-            <a:r>
-              <a:t>Tempo guida: 45 secondi.</a:t>
-            </a:r>
-          </a:p>
-          <a:p>
-            <a:endParaRPr/>
-          </a:p>
-          <a:p>
-            <a:r>
-              <a:t>Nelle condizioni studiate non è stata supportata la differenza prevista nella ricerca tra guadagno e perdita, benché la felicità differisse. Per proseguire la stessa domanda si potrebbero utilizzare standard più personalizzati e rilevanti per il sé, e lasciare una maggiore libertà di scelta tra roulette e domini. Un’altra strada è chiedersi se il dominio riguardi altre componenti del confronto sociale, oltre alla ricerca attiva qui esaminata. Sono proposte per studi futuri, non risultati già dimostrati.</a:t>
-            </a:r>
-          </a:p>
-          <a:p>
-            <a:r>
-              <a:t>Fonte: slide 27 originale e empirical_study.qmd, Limitations and Future Research.</a:t>
-            </a:r>
-          </a:p>
+          <a:p/>
         </p:txBody>
       </p:sp>
       <p:sp>
@@ -1997,76 +1386,7 @@
         <p:txBody>
           <a:bodyPr/>
           <a:lstStyle/>
-          <a:p>
-            <a:r>
-              <a:t>Gerber, J. P., Wheeler, L., &amp; Suls, J. (2018). A social comparison theory meta-analysis 60+ years on. Psychological Bulletin, 144(2), 177–197.</a:t>
-            </a:r>
-          </a:p>
-          <a:p>
-            <a:r>
-              <a:t>https://doi.org/10.1037/bul0000127</a:t>
-            </a:r>
-          </a:p>
-          <a:p>
-            <a:r>
-              <a:t>Hein, G., Silani, G., Preuschoff, K., Batson, C. D., &amp; Singer, T. (2010). Neural responses to ingroup and outgroup members’ suffering predict individual differences in costly helping. Neuron, 68(1), 149–160.</a:t>
-            </a:r>
-          </a:p>
-          <a:p>
-            <a:r>
-              <a:t>https://doi.org/10.1016/j.neuron.2010.09.003</a:t>
-            </a:r>
-          </a:p>
-          <a:p>
-            <a:r>
-              <a:t>Kahneman, D., &amp; Tversky, A. (1979). Prospect theory: An analysis of decision under risk. Econometrica, 47(2), 263–291.</a:t>
-            </a:r>
-          </a:p>
-          <a:p>
-            <a:r>
-              <a:t>https://doi.org/10.2307/1914185</a:t>
-            </a:r>
-          </a:p>
-          <a:p>
-            <a:r>
-              <a:t>Möller, J. (2016). The generalized internal/external frame of reference model: An extension to dimensional comparison theory. Frontline Learning Research, 4, 1–11.</a:t>
-            </a:r>
-          </a:p>
-          <a:p>
-            <a:r>
-              <a:t>https://doi.org/10.14786/flr.v4i2.169</a:t>
-            </a:r>
-          </a:p>
-          <a:p>
-            <a:r>
-              <a:t>Mussweiler, T. (2003). Comparison processes in social judgment: Mechanisms and consequences. Psychological Review, 110(3), 472–489.</a:t>
-            </a:r>
-          </a:p>
-          <a:p>
-            <a:r>
-              <a:t>https://doi.org/10.1037/0033-295X.110.3.472</a:t>
-            </a:r>
-          </a:p>
-          <a:p>
-            <a:r>
-              <a:t>Nabi, R. L., Walter, N., Oshidary, N., Endacott, C. G., Love-Nichols, J., Lew, Z. J., &amp; Aune, A. (2020). Can emotions capture the elusive gain-loss framing effect? A meta-analysis. Communication Research, 47(8), 1107–1130.</a:t>
-            </a:r>
-          </a:p>
-          <a:p>
-            <a:r>
-              <a:t>https://doi.org/10.1177/0093650219861256</a:t>
-            </a:r>
-          </a:p>
-          <a:p>
-            <a:r>
-              <a:t>Postmes, T., Haslam, S. A., &amp; Jans, L. (2013). A single-item measure of social identification: Reliability, validity, and utility. British Journal of Social Psychology, 52(4), 597–617.</a:t>
-            </a:r>
-          </a:p>
-          <a:p>
-            <a:r>
-              <a:t>https://doi.org/10.1111/bjso.12006</a:t>
-            </a:r>
-          </a:p>
+          <a:p/>
         </p:txBody>
       </p:sp>
       <p:sp>
@@ -2139,66 +1459,7 @@
         <p:txBody>
           <a:bodyPr/>
           <a:lstStyle/>
-          <a:p>
-            <a:r>
-              <a:t>Pyszczynski, T., Greenberg, J., &amp; LaPrelle, J. (1985). Social comparison after success and failure: Biased search for information consistent with a self-serving conclusion. Journal of Experimental Social Psychology, 21(2), 195–211.</a:t>
-            </a:r>
-          </a:p>
-          <a:p>
-            <a:r>
-              <a:t>https://doi.org/10.1016/0022-1031(85)90015-0</a:t>
-            </a:r>
-          </a:p>
-          <a:p>
-            <a:r>
-              <a:t>Rutledge, R. B., de Berker, A. O., Espenhahn, S., Dayan, P., &amp; Dolan, R. J. (2016). The social contingency of momentary subjective well-being. Nature Communications, 7(1), 11825.</a:t>
-            </a:r>
-          </a:p>
-          <a:p>
-            <a:r>
-              <a:t>https://doi.org/10.1038/ncomms11825</a:t>
-            </a:r>
-          </a:p>
-          <a:p>
-            <a:r>
-              <a:t>Singer, T., &amp; Klimecki, O. M. (2014). Empathy and compassion. Current Biology, 24(18), R875–R878.</a:t>
-            </a:r>
-          </a:p>
-          <a:p>
-            <a:r>
-              <a:t>https://doi.org/10.1016/j.cub.2014.06.054</a:t>
-            </a:r>
-          </a:p>
-          <a:p>
-            <a:r>
-              <a:t>van Lieshout, L. L. F., de Lange, F. P., &amp; Cools, R. (2021). Uncertainty increases curiosity, but decreases happiness. Scientific Reports, 11, 14014.</a:t>
-            </a:r>
-          </a:p>
-          <a:p>
-            <a:r>
-              <a:t>https://doi.org/10.1038/s41598-021-93464-6</a:t>
-            </a:r>
-          </a:p>
-          <a:p>
-            <a:r>
-              <a:t>White, K., &amp; Lehman, D. R. (2005). Culture and social comparison seeking: The role of self-motives. Personality and Social Psychology Bulletin, 31(2), 232–242.</a:t>
-            </a:r>
-          </a:p>
-          <a:p>
-            <a:r>
-              <a:t>https://doi.org/10.1177/0146167204271326</a:t>
-            </a:r>
-          </a:p>
-          <a:p>
-            <a:r>
-              <a:t>Young, N. A., Shuster, M. M., &amp; Mikels, J. A. (2019). The sure thing: The role of integral affect in risky choice framing. Emotion, 19(6), 1035–1043.</a:t>
-            </a:r>
-          </a:p>
-          <a:p>
-            <a:r>
-              <a:t>https://doi.org/10.1037/emo0000505</a:t>
-            </a:r>
-          </a:p>
+          <a:p/>
         </p:txBody>
       </p:sp>
       <p:sp>
@@ -2271,364 +1532,7 @@
         <p:txBody>
           <a:bodyPr/>
           <a:lstStyle/>
-          <a:p>
-            <a:r>
-              <a:rPr dirty="0"/>
-              <a:t>Tempo </a:t>
-            </a:r>
-            <a:r>
-              <a:rPr dirty="0" err="1"/>
-              <a:t>guida</a:t>
-            </a:r>
-            <a:r>
-              <a:rPr dirty="0"/>
-              <a:t>: 20 secondi.</a:t>
-            </a:r>
-          </a:p>
-          <a:p>
-            <a:r>
-              <a:rPr dirty="0"/>
-              <a:t>Lo studio </a:t>
-            </a:r>
-            <a:r>
-              <a:rPr dirty="0" err="1"/>
-              <a:t>si</a:t>
-            </a:r>
-            <a:r>
-              <a:rPr dirty="0"/>
-              <a:t> </a:t>
-            </a:r>
-            <a:r>
-              <a:rPr dirty="0" err="1"/>
-              <a:t>chiede</a:t>
-            </a:r>
-            <a:r>
-              <a:rPr dirty="0"/>
-              <a:t> se </a:t>
-            </a:r>
-            <a:r>
-              <a:rPr dirty="0" err="1"/>
-              <a:t>i</a:t>
-            </a:r>
-            <a:r>
-              <a:rPr dirty="0"/>
-              <a:t> domini di </a:t>
-            </a:r>
-            <a:r>
-              <a:rPr dirty="0" err="1"/>
-              <a:t>guadagno</a:t>
-            </a:r>
-            <a:r>
-              <a:rPr dirty="0"/>
-              <a:t> e di </a:t>
-            </a:r>
-            <a:r>
-              <a:rPr dirty="0" err="1"/>
-              <a:t>perdita</a:t>
-            </a:r>
-            <a:r>
-              <a:rPr dirty="0"/>
-              <a:t> </a:t>
-            </a:r>
-            <a:r>
-              <a:rPr dirty="0" err="1"/>
-              <a:t>influenzino</a:t>
-            </a:r>
-            <a:r>
-              <a:rPr dirty="0"/>
-              <a:t> la </a:t>
-            </a:r>
-            <a:r>
-              <a:rPr dirty="0" err="1"/>
-              <a:t>ricerca</a:t>
-            </a:r>
-            <a:r>
-              <a:rPr dirty="0"/>
-              <a:t> di </a:t>
-            </a:r>
-            <a:r>
-              <a:rPr dirty="0" err="1"/>
-              <a:t>confronto</a:t>
-            </a:r>
-            <a:r>
-              <a:rPr dirty="0"/>
-              <a:t> </a:t>
-            </a:r>
-            <a:r>
-              <a:rPr dirty="0" err="1"/>
-              <a:t>sociale</a:t>
-            </a:r>
-            <a:r>
-              <a:rPr dirty="0"/>
-              <a:t>. La </a:t>
-            </a:r>
-            <a:r>
-              <a:rPr dirty="0" err="1"/>
-              <a:t>domanda</a:t>
-            </a:r>
-            <a:r>
-              <a:rPr dirty="0"/>
-              <a:t> </a:t>
-            </a:r>
-            <a:r>
-              <a:rPr dirty="0" err="1"/>
-              <a:t>riguarda</a:t>
-            </a:r>
-            <a:r>
-              <a:rPr dirty="0"/>
-              <a:t> la </a:t>
-            </a:r>
-            <a:r>
-              <a:rPr dirty="0" err="1"/>
-              <a:t>scelta</a:t>
-            </a:r>
-            <a:r>
-              <a:rPr dirty="0"/>
-              <a:t> </a:t>
-            </a:r>
-            <a:r>
-              <a:rPr dirty="0" err="1"/>
-              <a:t>volontaria</a:t>
-            </a:r>
-            <a:r>
-              <a:rPr dirty="0"/>
-              <a:t> di </a:t>
-            </a:r>
-            <a:r>
-              <a:rPr dirty="0" err="1"/>
-              <a:t>cercare</a:t>
-            </a:r>
-            <a:r>
-              <a:rPr dirty="0"/>
-              <a:t> </a:t>
-            </a:r>
-            <a:r>
-              <a:rPr dirty="0" err="1"/>
-              <a:t>informazioni</a:t>
-            </a:r>
-            <a:r>
-              <a:rPr dirty="0"/>
-              <a:t> </a:t>
-            </a:r>
-            <a:r>
-              <a:rPr dirty="0" err="1"/>
-              <a:t>sugli</a:t>
-            </a:r>
-            <a:r>
-              <a:rPr dirty="0"/>
-              <a:t> </a:t>
-            </a:r>
-            <a:r>
-              <a:rPr dirty="0" err="1"/>
-              <a:t>esiti</a:t>
-            </a:r>
-            <a:r>
-              <a:rPr dirty="0"/>
-              <a:t> </a:t>
-            </a:r>
-            <a:r>
-              <a:rPr dirty="0" err="1"/>
-              <a:t>altrui</a:t>
-            </a:r>
-            <a:r>
-              <a:rPr dirty="0"/>
-              <a:t> ed è </a:t>
-            </a:r>
-            <a:r>
-              <a:rPr dirty="0" err="1"/>
-              <a:t>presentata</a:t>
-            </a:r>
-            <a:r>
-              <a:rPr dirty="0"/>
-              <a:t> come </a:t>
-            </a:r>
-            <a:r>
-              <a:rPr dirty="0" err="1"/>
-              <a:t>aperta</a:t>
-            </a:r>
-            <a:r>
-              <a:rPr dirty="0"/>
-              <a:t> </a:t>
-            </a:r>
-            <a:r>
-              <a:rPr dirty="0" err="1"/>
-              <a:t>nella</a:t>
-            </a:r>
-            <a:r>
-              <a:rPr dirty="0"/>
-              <a:t> </a:t>
-            </a:r>
-            <a:r>
-              <a:rPr dirty="0" err="1"/>
-              <a:t>letteratura</a:t>
-            </a:r>
-            <a:r>
-              <a:rPr dirty="0"/>
-              <a:t> </a:t>
-            </a:r>
-            <a:r>
-              <a:rPr dirty="0" err="1"/>
-              <a:t>considerata</a:t>
-            </a:r>
-            <a:r>
-              <a:rPr dirty="0"/>
-              <a:t> </a:t>
-            </a:r>
-            <a:r>
-              <a:rPr dirty="0" err="1"/>
-              <a:t>dalla</a:t>
-            </a:r>
-            <a:r>
-              <a:rPr dirty="0"/>
-              <a:t> </a:t>
-            </a:r>
-            <a:r>
-              <a:rPr dirty="0" err="1"/>
-              <a:t>tesi</a:t>
-            </a:r>
-            <a:r>
-              <a:rPr dirty="0"/>
-              <a:t>.</a:t>
-            </a:r>
-          </a:p>
-          <a:p>
-            <a:r>
-              <a:rPr dirty="0" err="1"/>
-              <a:t>Riferimento</a:t>
-            </a:r>
-            <a:r>
-              <a:rPr dirty="0"/>
-              <a:t> per il </a:t>
-            </a:r>
-            <a:r>
-              <a:rPr dirty="0" err="1"/>
-              <a:t>razionale</a:t>
-            </a:r>
-            <a:r>
-              <a:rPr dirty="0"/>
-              <a:t>: </a:t>
-            </a:r>
-            <a:r>
-              <a:rPr dirty="0" err="1"/>
-              <a:t>MasterThesis</a:t>
-            </a:r>
-            <a:r>
-              <a:rPr dirty="0"/>
-              <a:t>/</a:t>
-            </a:r>
-            <a:r>
-              <a:rPr dirty="0" err="1"/>
-              <a:t>empirical_study.qmd</a:t>
-            </a:r>
-            <a:r>
-              <a:rPr dirty="0"/>
-              <a:t>, Study Rationale and Hypotheses. Il gap </a:t>
-            </a:r>
-            <a:r>
-              <a:rPr dirty="0" err="1"/>
-              <a:t>riguarda</a:t>
-            </a:r>
-            <a:r>
-              <a:rPr dirty="0"/>
-              <a:t> la </a:t>
-            </a:r>
-            <a:r>
-              <a:rPr dirty="0" err="1"/>
-              <a:t>ricerca</a:t>
-            </a:r>
-            <a:r>
-              <a:rPr dirty="0"/>
-              <a:t> </a:t>
-            </a:r>
-            <a:r>
-              <a:rPr dirty="0" err="1"/>
-              <a:t>attiva</a:t>
-            </a:r>
-            <a:r>
-              <a:rPr dirty="0"/>
-              <a:t> di </a:t>
-            </a:r>
-            <a:r>
-              <a:rPr dirty="0" err="1"/>
-              <a:t>informazioni</a:t>
-            </a:r>
-            <a:r>
-              <a:rPr dirty="0"/>
-              <a:t> di </a:t>
-            </a:r>
-            <a:r>
-              <a:rPr dirty="0" err="1"/>
-              <a:t>confronto</a:t>
-            </a:r>
-            <a:r>
-              <a:rPr dirty="0"/>
-              <a:t>, non ogni </a:t>
-            </a:r>
-            <a:r>
-              <a:rPr dirty="0" err="1"/>
-              <a:t>relazione</a:t>
-            </a:r>
-            <a:r>
-              <a:rPr dirty="0"/>
-              <a:t> </a:t>
-            </a:r>
-            <a:r>
-              <a:rPr dirty="0" err="1"/>
-              <a:t>tra</a:t>
-            </a:r>
-            <a:r>
-              <a:rPr dirty="0"/>
-              <a:t> domini e </a:t>
-            </a:r>
-            <a:r>
-              <a:rPr dirty="0" err="1"/>
-              <a:t>confronto</a:t>
-            </a:r>
-            <a:r>
-              <a:rPr dirty="0"/>
-              <a:t> </a:t>
-            </a:r>
-            <a:r>
-              <a:rPr dirty="0" err="1"/>
-              <a:t>sociale</a:t>
-            </a:r>
-            <a:r>
-              <a:rPr dirty="0"/>
-              <a:t>. Non </a:t>
-            </a:r>
-            <a:r>
-              <a:rPr dirty="0" err="1"/>
-              <a:t>si</a:t>
-            </a:r>
-            <a:r>
-              <a:rPr dirty="0"/>
-              <a:t> </a:t>
-            </a:r>
-            <a:r>
-              <a:rPr dirty="0" err="1"/>
-              <a:t>afferma</a:t>
-            </a:r>
-            <a:r>
-              <a:rPr dirty="0"/>
-              <a:t> </a:t>
-            </a:r>
-            <a:r>
-              <a:rPr dirty="0" err="1"/>
-              <a:t>un’assenza</a:t>
-            </a:r>
-            <a:r>
-              <a:rPr dirty="0"/>
-              <a:t> assoluta di </a:t>
-            </a:r>
-            <a:r>
-              <a:rPr dirty="0" err="1"/>
-              <a:t>studi</a:t>
-            </a:r>
-            <a:r>
-              <a:rPr dirty="0"/>
-              <a:t>.</a:t>
-            </a:r>
-          </a:p>
+          <a:p/>
         </p:txBody>
       </p:sp>
       <p:sp>
@@ -2701,11 +1605,7 @@
         <p:txBody>
           <a:bodyPr/>
           <a:lstStyle/>
-          <a:p>
-            <a:r>
-              <a:t>Chiusura istituzionale. Le due slide successive sono supplementari e fuori dal percorso di 12 minuti.</a:t>
-            </a:r>
-          </a:p>
+          <a:p/>
         </p:txBody>
       </p:sp>
       <p:sp>
@@ -2778,41 +1678,7 @@
         <p:txBody>
           <a:bodyPr/>
           <a:lstStyle/>
-          <a:p>
-            <a:r>
-              <a:t>Effetto d’ordine: analisi preliminare, 840 trial da 140 partecipanti.</a:t>
-            </a:r>
-          </a:p>
-          <a:p>
-            <a:r>
-              <a:t>Grafici descrittivi: medie per partecipante nelle celle dominio per posizione e IC 95%; estensione limitata ai trial con richieste. I grafici non rappresentano predizioni del modello. Grafici rigenerati dalla funzione plot_preliminary_carryover del sorgente della tesi; cambiate soltanto le etichette, omesso il titolo interno ripetuto nelle intestazioni della slide e adattate le dimensioni alla slide. Stesse scale, colori, punti circolari, separazione orizzontale dei domini e IC della tesi. Immagini statiche ad alta risoluzione richieste per fedeltà alle figure originali.</a:t>
-            </a:r>
-          </a:p>
-          <a:p>
-            <a:r>
-              <a:t>Risultati: modello misto hurdle-Poisson; secondo rispetto al primo blocco. Coefficiente zero invertito per descrivere le odds di almeno una richiesta.</a:t>
-            </a:r>
-          </a:p>
-          <a:p>
-            <a:r>
-              <a:t>L’interazione non significativa non dimostra equivalenza tra domini o assenza di carryover; IC dell’interazione ampio. Sequenze: 73 guadagno-perdita, 67 perdita-guadagno.</a:t>
-            </a:r>
-          </a:p>
-          <a:p>
-            <a:r>
-              <a:t>Fonti tesi: MasterThesis/empirical_study.qmd, Preliminary analysis; MasterThesis/appendix_preliminary_analyses.qmd.</a:t>
-            </a:r>
-          </a:p>
-          <a:p>
-            <a:r>
-              <a:t>Output: C:/Users/LG/Documents/SC_Project/SocialComparison_Analysis/outputs/glmm_analysis/carryover_check/any_sampling_by_block_position_and_domain_summary.csv; sampling_amount_by_block_position_and_domain_summary.csv; domain_block_order_model_fixed_effects.csv.</a:t>
-            </a:r>
-          </a:p>
-          <a:p>
-            <a:r>
-              <a:t>Valori verificati sugli output salvati, senza rifit.</a:t>
-            </a:r>
-          </a:p>
+          <a:p/>
         </p:txBody>
       </p:sp>
       <p:sp>
@@ -2885,24 +1751,7 @@
         <p:txBody>
           <a:bodyPr/>
           <a:lstStyle/>
-          <a:p>
-            <a:r>
-              <a:t>Tempo guida: 40 secondi.</a:t>
-            </a:r>
-          </a:p>
-          <a:p>
-            <a:endParaRPr/>
-          </a:p>
-          <a:p>
-            <a:r>
-              <a:t>Per confronto sociale intendiamo considerare informazioni sugli altri in relazione al sé. Possiamo distinguere quattro componenti: scegliere il target di valutazione, selezionare uno standard, comparare e valutare. Sono componenti concettuali che possono sovrapporsi, non una sequenza obbligata. Il focus è la ricerca attiva dello standard. Separatamente, guadagno e perdita dipendono dal riferimento: arrivare a trenta euro partendo da zero o da sessanta significa raggiungere lo stesso importo finale con variazioni opposte. Il punto grande indica sempre il riferimento, quello piccolo l’esito.</a:t>
-            </a:r>
-          </a:p>
-          <a:p>
-            <a:r>
-              <a:t>Fonti: theoretical_background.qmd, Comparison as a Process e Prospect Theory.</a:t>
-            </a:r>
-          </a:p>
+          <a:p/>
         </p:txBody>
       </p:sp>
       <p:sp>
@@ -2975,24 +1824,7 @@
         <p:txBody>
           <a:bodyPr/>
           <a:lstStyle/>
-          <a:p>
-            <a:r>
-              <a:t>Tempo guida: 25 secondi.</a:t>
-            </a:r>
-          </a:p>
-          <a:p>
-            <a:endParaRPr/>
-          </a:p>
-          <a:p>
-            <a:r>
-              <a:t>La prima ipotesi prevedeva una minore ricerca di confronto sociale nel dominio di perdita rispetto al dominio di guadagno. La direzione attesa riguarda la richiesta di informazioni. La differenza nella felicità tra i blocchi viene invece esaminata separatamente come controllo della manipolazione.</a:t>
-            </a:r>
-          </a:p>
-          <a:p>
-            <a:r>
-              <a:t>Fonte: empirical_study.qmd, H1, righe 27–29.</a:t>
-            </a:r>
-          </a:p>
+          <a:p/>
         </p:txBody>
       </p:sp>
       <p:sp>
@@ -3065,69 +1897,7 @@
         <p:txBody>
           <a:bodyPr/>
           <a:lstStyle/>
-          <a:p>
-            <a:r>
-              <a:t>Tempo guida: circa 60 secondi.</a:t>
-            </a:r>
-          </a:p>
-          <a:p>
-            <a:endParaRPr/>
-          </a:p>
-          <a:p>
-            <a:r>
-              <a:t>H2 proponeva l’identificazione come possibile mediatore. H2a prevedeva maggiore identificazione nella perdita rispetto al guadagno. H2b prevedeva minore ricerca di confronto sociale al crescere dell’identificazione.</a:t>
-            </a:r>
-          </a:p>
-          <a:p>
-            <a:endParaRPr/>
-          </a:p>
-          <a:p>
-            <a:r>
-              <a:t>Spiegazione del razionale di H2b: una maggiore identificazione avrebbe potuto favorire una risposta empatica agli esiti altrui. Se questa risposta avesse assunto la forma di un disagio personale sufficientemente avversivo, evitare ulteriori informazioni avrebbe potuto essere un modo per ridurre il proprio disagio. Da qui la previsione di minore ricerca di confronto sociale. Questa è la sequenza ipotizzata per motivare H2b, non una catena causale verificata nel compito.</a:t>
-            </a:r>
-          </a:p>
-          <a:p>
-            <a:endParaRPr/>
-          </a:p>
-          <a:p>
-            <a:r>
-              <a:t>Promemoria teorico per il relatore: risposta empatica è un termine generale. La preoccupazione empatica orientata all’altro può accompagnarsi ad avvicinamento e aiuto; il disagio personale è orientato alla riduzione della propria attivazione avversiva. Non si assume che la preoccupazione empatica si trasformi nel disagio personale. Il razionale qui presentato riguarda soltanto la possibilità che la risposta assuma la forma di disagio personale.</a:t>
-            </a:r>
-          </a:p>
-          <a:p>
-            <a:endParaRPr/>
-          </a:p>
-          <a:p>
-            <a:r>
-              <a:t>Risposta empatica, disagio personale e intenzione di evitare non erano misurati direttamente. Una minore ricerca sarebbe compatibile con l’evitamento ipotizzato, ma non lo dimostrerebbe. Il riferimento alla perdita condivisa riguarda il razionale di H2a e rimane un’analogia con studi sull’avversità condivisa.</a:t>
-            </a:r>
-          </a:p>
-          <a:p>
-            <a:endParaRPr/>
-          </a:p>
-          <a:p>
-            <a:r>
-              <a:t>Fonti: MasterThesis/empirical_study.qmd, Hypotheses, paragrafi di H2; DefensePresentation/fonti-razionale-h2-risposta-empatica.md. Maki et al. (2019) e Drury et al. (2016): avversità condivisa e identificazione; Hein et al. (2010): risposta empatica relativa all’ingroup e aiuto, non verifica di identificazione individuale → evitamento; Batson et al. (1987) e Singer &amp; Klimecki (2014): distinzione tra risposte orientate all’altro e disagio personale. Nessuna di queste fonti dimostra l’intera catena nel compito della tesi.</a:t>
-            </a:r>
-          </a:p>
-          <a:p>
-            <a:endParaRPr/>
-          </a:p>
-          <a:p>
-            <a:r>
-              <a:t>Hein et al. (2010): https://doi.org/10.1016/j.neuron.2010.09.003</a:t>
-            </a:r>
-          </a:p>
-          <a:p>
-            <a:r>
-              <a:t>Batson et al. (1987): https://doi.org/10.1111/j.1467-6494.1987.tb00426.x</a:t>
-            </a:r>
-          </a:p>
-          <a:p>
-            <a:r>
-              <a:t>Singer &amp; Klimecki (2014): https://doi.org/10.1016/j.cub.2014.06.054</a:t>
-            </a:r>
-          </a:p>
+          <a:p/>
         </p:txBody>
       </p:sp>
       <p:sp>
@@ -3200,24 +1970,7 @@
         <p:txBody>
           <a:bodyPr/>
           <a:lstStyle/>
-          <a:p>
-            <a:r>
-              <a:t>Tempo guida: 25 secondi.</a:t>
-            </a:r>
-          </a:p>
-          <a:p>
-            <a:endParaRPr/>
-          </a:p>
-          <a:p>
-            <a:r>
-              <a:t>La terza ipotesi prevedeva una maggiore ricerca quando era possibile un confronto verso l’alto rispetto a quando era possibile un confronto verso il basso. La letteratura richiamata suggerisce una tendenza a preferire standard superiori, con limiti legati alle alternative disponibili. Qui la previsione riguarda la direzione resa disponibile dal compito. Non implica che le persone scelgano direttamente un target migliore.</a:t>
-            </a:r>
-          </a:p>
-          <a:p>
-            <a:r>
-              <a:t>Fonti: empirical_study.qmd, H3, righe 37–39.</a:t>
-            </a:r>
-          </a:p>
+          <a:p/>
         </p:txBody>
       </p:sp>
       <p:sp>
@@ -3290,24 +2043,7 @@
         <p:txBody>
           <a:bodyPr/>
           <a:lstStyle/>
-          <a:p>
-            <a:r>
-              <a:t>Tempo guida: 35 secondi.</a:t>
-            </a:r>
-          </a:p>
-          <a:p>
-            <a:endParaRPr/>
-          </a:p>
-          <a:p>
-            <a:r>
-              <a:t>Il disegno era entro soggetti: ciascuna persona completava un blocco di guadagno e uno di perdita, in ordine randomizzato. Ogni blocco comprendeva tre roulette. Nel guadagno si partiva da zero dollari; nella perdita da sessanta. Le variazioni differivano tra domini, ma gli importi finali possibili erano abbinati. Per esempio, più dieci e più cinquanta partendo da zero corrispondevano a meno cinquanta e meno dieci partendo da sessanta. Peggiore e migliore si riferiscono sempre alle due alternative della singola roulette.</a:t>
-            </a:r>
-          </a:p>
-          <a:p>
-            <a:r>
-              <a:t>Fonte: empirical_study.qmd, Design and Materials, righe 49–60.</a:t>
-            </a:r>
-          </a:p>
+          <a:p/>
         </p:txBody>
       </p:sp>
       <p:sp>
@@ -3380,29 +2116,7 @@
         <p:txBody>
           <a:bodyPr/>
           <a:lstStyle/>
-          <a:p>
-            <a:r>
-              <a:t>Tempo guida: 45 secondi.</a:t>
-            </a:r>
-          </a:p>
-          <a:p>
-            <a:endParaRPr/>
-          </a:p>
-          <a:p>
-            <a:r>
-              <a:t>Prima del compito: consenso, istruzioni e tutorial, verifica di comprensione. In ogni trial il partecipante fa girare la roulette e osserva il proprio esito. Può quindi richiedere gli esiti attribuiti ad altre persone: ogni pressione di J mostra un nome e un esito alla volta. Nome ed esito sono casuali e relativi alla roulette corrente. La richiesta può essere ripetuta oppure interrotta: con F si passa alla roulette successiva anche senza avere chiesto alcuna informazione. Le informazioni non modificano la vincita. La schermata mostra un esempio dopo tre richieste, non un limite al numero di richieste. Dopo ciascun blocco vengono rilevate felicità e identificazione; dopo i blocchi sono previsti attention check e debriefing.</a:t>
-            </a:r>
-          </a:p>
-          <a:p>
-            <a:r>
-              <a:t>Schermata fornita dall’autore: Screenshot 2026-10-10 175545.png, demo https://michelegarbelotto.github.io/CV/Experiment.html?cv_section=task. La demo è collegata nella precedente slide sul disegno sperimentale.</a:t>
-            </a:r>
-          </a:p>
-          <a:p>
-            <a:r>
-              <a:t>Fonte della procedura: MasterThesis/empirical_study.qmd, Procedure.</a:t>
-            </a:r>
-          </a:p>
+          <a:p/>
         </p:txBody>
       </p:sp>
       <p:sp>
@@ -3475,61 +2189,7 @@
         <p:txBody>
           <a:bodyPr/>
           <a:lstStyle/>
-          <a:p>
-            <a:r>
-              <a:t>Tempo guida: 35 secondi.</a:t>
-            </a:r>
-          </a:p>
-          <a:p>
-            <a:endParaRPr/>
-          </a:p>
-          <a:p>
-            <a:r>
-              <a:t>La misura primaria è il numero di esiti richiesti per roulette. Consente di distinguere l’inizio, cioè almeno una richiesta, dall’estensione una volta iniziata la ricerca. I lavori citati sono precedenti metodologici, non la stessa misura. Dopo ciascun blocco si rilevavano felicità momentanea e identificazione, entrambe con un singolo item adattato. La felicità era registrata su uno slider da zero a cento, l’identificazione su sette categorie. Non sono state somministrate le intere scale originali.</a:t>
-            </a:r>
-          </a:p>
-          <a:p>
-            <a:r>
-              <a:t>Fonte: empirical_study.qmd, Materials and Measures, righe 61–69.</a:t>
-            </a:r>
-          </a:p>
-          <a:p>
-            <a:r>
-              <a:t>Razionale aggiunto per il controllo della manipolazione. La previsione dello studio è minore felicità momentanea dopo il blocco di perdita rispetto al guadagno. Le fonti seguenti offrono evidenze complementari, con misure e tempi diversi dalla rilevazione post-blocco della tesi.</a:t>
-            </a:r>
-          </a:p>
-          <a:p>
-            <a:endParaRPr/>
-          </a:p>
-          <a:p>
-            <a:r>
-              <a:t>Nabi et al. (2020): meta-analisi di 25 studi sui messaggi persuasivi. Il frame di guadagno elicita più emozioni positive, quello di perdita più emozioni negative. Sostegno indiretto per un compito monetario. Locator: abstract del testo dell’editore. https://doi.org/10.1177/0093650219861256</a:t>
-            </a:r>
-          </a:p>
-          <a:p>
-            <a:endParaRPr/>
-          </a:p>
-          <a:p>
-            <a:r>
-              <a:t>Young et al. (2019): due esperimenti di framing monetario con esiti finali equivalenti. L’opzione certa evoca reazioni immediate più negative quando è presentata come perdita. La misura riguarda l’opzione prima della scelta, non la felicità generale dopo l’esito. Locator: Experiment 1, Method e Results; Experiment 2, Results, pp. 3–4 e 6 della versione online. https://doi.org/10.1037/emo0000505 ; PDF dell’autore: https://emocoglab.depaul.edu/publications/journals/Young_Shuster_Mikels_2018.pdf</a:t>
-            </a:r>
-          </a:p>
-          <a:p>
-            <a:endParaRPr/>
-          </a:p>
-          <a:p>
-            <a:r>
-              <a:t>van Lieshout et al. (2021): nell’esperimento 1 la felicità è maggiore per le lotterie con guadagni rispetto a quelle con perdite monetarie. Il giudizio riguarda la lotteria che verrà giocata, prima di conoscere l’esito. Gli esiti finali non sono equivalenti fra domini: non è una manipolazione pura di framing. Locator: Methods, Procedure; Results, Experiment 1; Figure 2A. https://doi.org/10.1038/s41598-021-93464-6</a:t>
-            </a:r>
-          </a:p>
-          <a:p>
-            <a:endParaRPr/>
-          </a:p>
-          <a:p>
-            <a:r>
-              <a:t>La previsione post-blocco è quindi un’estensione al disegno della tesi, non un risultato già dimostrato da queste fonti con la stessa manipolazione. Un effetto sulla felicità non dimostra, da solo, l’adozione del riferimento monetario previsto o l’avversione alla perdita. Rutledge et al. (2016) resta la fonte di adattamento dell’item, distinta dalle fonti della previsione. Felicità e identificazione restano singoli item adattati.</a:t>
-            </a:r>
-          </a:p>
+          <a:p/>
         </p:txBody>
       </p:sp>
       <p:sp>

</xml_diff>